<commit_message>
Recolour all decks to exact SEFW palette; split emotions into 2 Zoom sessions
Swap deck colours to the real SEFW brand hexes (navy #1d283c, plum #74234f,
blush #e4bbc2, pale pink #fce8ea, sage #7ca1a5, deep teal #224652, gold
#c9a86d); no rust/copper/cream. Save palette to my.md. Split Master Your
Emotions into two 2-hour Zoom sessions (Safety & Self-Compassion; Riding the
Waves & Tapping) with reflection questions and paired breakout exercises.
Add 'emotions are the messengers' line; simplify the body-braces wording.

Co-Authored-By: Claude Opus 4.8 <noreply@anthropic.com>
Claude-Session: https://claude.ai/code/session_01FhNN1xnUyELSQ3xs2X22yA
</commit_message>
<xml_diff>
--- a/content/sessions/slides/Matrix-Slides-Invisible-to-Present.pptx
+++ b/content/sessions/slides/Matrix-Slides-Invisible-to-Present.pptx
@@ -3085,7 +3085,7 @@
     <p:bg>
       <p:bgPr>
         <a:solidFill>
-          <a:srgbClr val="C2A46D"/>
+          <a:srgbClr val="C9A86D"/>
         </a:solidFill>
         <a:effectLst/>
       </p:bgPr>
@@ -3122,7 +3122,7 @@
             <a:r>
               <a:rPr sz="1500" b="1">
                 <a:solidFill>
-                  <a:srgbClr val="6E1A2E"/>
+                  <a:srgbClr val="74234F"/>
                 </a:solidFill>
                 <a:latin typeface="Lora"/>
               </a:rPr>
@@ -3156,7 +3156,7 @@
             <a:r>
               <a:rPr sz="4000">
                 <a:solidFill>
-                  <a:srgbClr val="15110D"/>
+                  <a:srgbClr val="1D283C"/>
                 </a:solidFill>
                 <a:latin typeface="Marcellus"/>
               </a:rPr>
@@ -3180,7 +3180,7 @@
             <a:avLst/>
           </a:prstGeom>
           <a:solidFill>
-            <a:srgbClr val="6E1A2E"/>
+            <a:srgbClr val="74234F"/>
           </a:solidFill>
           <a:ln>
             <a:noFill/>
@@ -3239,7 +3239,7 @@
             <a:r>
               <a:rPr sz="2700" i="0">
                 <a:solidFill>
-                  <a:srgbClr val="15110D"/>
+                  <a:srgbClr val="1D283C"/>
                 </a:solidFill>
                 <a:latin typeface="Lora"/>
               </a:rPr>
@@ -3273,7 +3273,7 @@
             <a:r>
               <a:rPr sz="1100">
                 <a:solidFill>
-                  <a:srgbClr val="6E1A2E"/>
+                  <a:srgbClr val="74234F"/>
                 </a:solidFill>
                 <a:latin typeface="Lora"/>
               </a:rPr>
@@ -3296,7 +3296,7 @@
     <p:bg>
       <p:bgPr>
         <a:solidFill>
-          <a:srgbClr val="1F2A44"/>
+          <a:srgbClr val="1D283C"/>
         </a:solidFill>
         <a:effectLst/>
       </p:bgPr>
@@ -3333,7 +3333,7 @@
             <a:r>
               <a:rPr sz="1500" b="1">
                 <a:solidFill>
-                  <a:srgbClr val="C2A46D"/>
+                  <a:srgbClr val="C9A86D"/>
                 </a:solidFill>
                 <a:latin typeface="Lora"/>
               </a:rPr>
@@ -3367,7 +3367,7 @@
             <a:r>
               <a:rPr sz="4000">
                 <a:solidFill>
-                  <a:srgbClr val="F5EFE3"/>
+                  <a:srgbClr val="FCE8EA"/>
                 </a:solidFill>
                 <a:latin typeface="Marcellus"/>
               </a:rPr>
@@ -3391,7 +3391,7 @@
             <a:avLst/>
           </a:prstGeom>
           <a:solidFill>
-            <a:srgbClr val="C2A46D"/>
+            <a:srgbClr val="C9A86D"/>
           </a:solidFill>
           <a:ln>
             <a:noFill/>
@@ -3450,7 +3450,7 @@
             <a:r>
               <a:rPr sz="2700" i="0">
                 <a:solidFill>
-                  <a:srgbClr val="F5EFE3"/>
+                  <a:srgbClr val="FCE8EA"/>
                 </a:solidFill>
                 <a:latin typeface="Lora"/>
               </a:rPr>
@@ -3484,7 +3484,7 @@
             <a:r>
               <a:rPr sz="1100">
                 <a:solidFill>
-                  <a:srgbClr val="C2A46D"/>
+                  <a:srgbClr val="C9A86D"/>
                 </a:solidFill>
                 <a:latin typeface="Lora"/>
               </a:rPr>

</xml_diff>